<commit_message>
Mapa de encaixe das ofertas + propagação das 5 mudanças na identidade e no deck
- Jornada README: tabela 'o que se vende, onde e por quê' (Conselheiro com
  as 2 portas, camadas na renovação, turma, volante do vault)
- Posicionamento 90s: porta lateral do Conselheiro no pitch
- Modelo de serviço: etapa 5 em 3 camadas
- Deck institucional regenerado: slide 6 etapas cita camadas e o Conselheiro

Co-Authored-By: Claude Fable 5 <noreply@anthropic.com>
Claude-Session: https://claude.ai/code/session_016RZJT8nVEB7u33HvjY5KvZ
</commit_message>
<xml_diff>
--- a/08-materiais/modelos/abba-deck-institucional.pptx
+++ b/08-materiais/modelos/abba-deck-institucional.pptx
@@ -6434,7 +6434,7 @@
                 <a:ea typeface="Calibri" pitchFamily="34" charset="-122"/>
                 <a:cs typeface="Calibri" pitchFamily="34" charset="-120"/>
               </a:rPr>
-              <a:t>Operação contínua com SLA e relatório mensal de impacto</a:t>
+              <a:t>Operação contínua em 3 camadas, com SLA e relatório mensal de impacto</a:t>
             </a:r>
             <a:endParaRPr lang="en-US" sz="1150" dirty="0"/>
           </a:p>
@@ -6570,7 +6570,7 @@
                 <a:ea typeface="Calibri" pitchFamily="34" charset="-122"/>
                 <a:cs typeface="Calibri" pitchFamily="34" charset="-120"/>
               </a:rPr>
-              <a:t>Ritual trimestral: resultados contra os objetivos que VOCÊS declararam. Nós recomendamos com convicção; a decisão é sua.</a:t>
+              <a:t>Ritual trimestral: resultados contra os objetivos que VOCÊS declararam. Nós recomendamos com convicção; a decisão é sua. Também disponível como produto contínuo: o Conselheiro de IA ABBA.</a:t>
             </a:r>
             <a:endParaRPr lang="en-US" sz="1400" dirty="0"/>
           </a:p>

</xml_diff>

<commit_message>
Padrão editorial: apresentação vira o documento-padrão + varredura de alinhamento em todo o repo
- 08-materiais/README §0: o padrão editorial registrado (entonação e termos da apresentação)
- Deck institucional: 25 dimensões → mergulho profundo; agentes sob medida → engenharia sob medida (V3m)
- Deck do Conselheiro: slide 7 sem 'firma nova' (honestidade mantida)
- Análise ABBA modelo: 25 dimensões removido + discurso de engenharia
- One-pager Conselheiro + spec assessment web: comercial@ → contato@
- Kit de presença e catálogo: descrições atualizadas para a versão vigente
- Régua do Revisor v1.1.0: primeiro-cafe (block), firma-nova (warn), 25-dimensoes (warn)
- V-log V3p

Co-Authored-By: Claude Fable 5 <noreply@anthropic.com>
Claude-Session: https://claude.ai/code/session_016RZJT8nVEB7u33HvjY5KvZ
</commit_message>
<xml_diff>
--- a/08-materiais/modelos/abba-deck-institucional.pptx
+++ b/08-materiais/modelos/abba-deck-institucional.pptx
@@ -5685,7 +5685,7 @@
                 <a:ea typeface="Calibri" pitchFamily="34" charset="-122"/>
                 <a:cs typeface="Calibri" pitchFamily="34" charset="-120"/>
               </a:rPr>
-              <a:t>Avaliação da empresa em 25 dimensões, com dado e quantificação por trás de cada recomendação.</a:t>
+              <a:t>Avaliação profunda da empresa, do conselho à linha de frente, com dado e quantificação por trás de cada recomendação.</a:t>
             </a:r>
             <a:endParaRPr lang="en-US" sz="1300" dirty="0"/>
           </a:p>
@@ -5977,7 +5977,7 @@
                 <a:ea typeface="Calibri" pitchFamily="34" charset="-122"/>
                 <a:cs typeface="Calibri" pitchFamily="34" charset="-120"/>
               </a:rPr>
-              <a:t>Agentes sob medida em produção, com pontos de aprovação humana — na sua infraestrutura ou em nuvem.</a:t>
+              <a:t>Engenharia sob medida — arquitetura, integrações e agentes de IA em produção, com pontos de aprovação humana; na sua infraestrutura ou em nuvem.</a:t>
             </a:r>
             <a:endParaRPr lang="en-US" sz="1300" dirty="0"/>
           </a:p>
@@ -6610,7 +6610,7 @@
                 <a:ea typeface="Calibri" pitchFamily="34" charset="-122"/>
                 <a:cs typeface="Calibri" pitchFamily="34" charset="-120"/>
               </a:rPr>
-              <a:t>25 dimensões, do conselho à linha de frente, com quantificação</a:t>
+              <a:t>Mergulho profundo, do conselho à linha de frente, com quantificação</a:t>
             </a:r>
             <a:endParaRPr lang="en-US" sz="1150" dirty="0"/>
           </a:p>
@@ -6775,7 +6775,7 @@
                 <a:ea typeface="Calibri" pitchFamily="34" charset="-122"/>
                 <a:cs typeface="Calibri" pitchFamily="34" charset="-120"/>
               </a:rPr>
-              <a:t>Agentes sob medida, on-premises ou nuvem gerenciada</a:t>
+              <a:t>Engenharia sob medida: arquitetura, integrações e agentes, on-premises ou nuvem</a:t>
             </a:r>
             <a:endParaRPr lang="en-US" sz="1150" dirty="0"/>
           </a:p>
@@ -8206,7 +8206,7 @@
                 <a:ea typeface="Calibri" pitchFamily="34" charset="-122"/>
                 <a:cs typeface="Calibri" pitchFamily="34" charset="-120"/>
               </a:rPr>
-              <a:t>Fica com você: portfólio de oportunidades ranqueado e quantificado (25 dimensões) + plano diretor 6–12 meses</a:t>
+              <a:t>Fica com você: portfólio de oportunidades ranqueado e quantificado + plano diretor 6–12 meses</a:t>
             </a:r>
             <a:endParaRPr lang="en-US" sz="1150" dirty="0"/>
           </a:p>
@@ -8349,7 +8349,7 @@
                 <a:ea typeface="Calibri" pitchFamily="34" charset="-122"/>
                 <a:cs typeface="Calibri" pitchFamily="34" charset="-120"/>
               </a:rPr>
-              <a:t>Fica com você: agente funcional validado com dados reais e usuários-chave — decisão GO/NO-GO com número</a:t>
+              <a:t>Fica com você: solução funcional validada com dados reais e usuários-chave — decisão GO/NO-GO com número</a:t>
             </a:r>
             <a:endParaRPr lang="en-US" sz="1150" dirty="0"/>
           </a:p>
@@ -10000,7 +10000,7 @@
                 <a:ea typeface="Calibri" pitchFamily="34" charset="-122"/>
                 <a:cs typeface="Calibri" pitchFamily="34" charset="-120"/>
               </a:rPr>
-              <a:t>Avaliação em 25 dimensões</a:t>
+              <a:t>Avaliação profunda da empresa inteira</a:t>
             </a:r>
             <a:endParaRPr lang="en-US" sz="1450" dirty="0"/>
           </a:p>

</xml_diff>